<commit_message>
Add 4/5 Conquering Through Christ Sunday School materials and update 3/22 lesson
Co-Authored-By: Claude Opus 4.6 (1M context) <noreply@anthropic.com>
</commit_message>
<xml_diff>
--- a/ECC Sunday School - Becoming a Living Sacrifice (Slides).pptx
+++ b/ECC Sunday School - Becoming a Living Sacrifice (Slides).pptx
@@ -4421,7 +4421,7 @@
               </a:defRPr>
             </a:pPr>
             <a:r>
-              <a:t>▸  If God told you that you couldn't lie anymore — would that cramp your lifestyle?</a:t>
+              <a:t>▸  The world says: "You do you" — moral relativism, no absolute right or wrong</a:t>
             </a:r>
           </a:p>
         </p:txBody>
@@ -4457,7 +4457,7 @@
               </a:defRPr>
             </a:pPr>
             <a:r>
-              <a:t>▸  Example: parents lying about their kid's age for a discount</a:t>
+              <a:t>▸  As Christians: we trust God's wisdom to define right and wrong</a:t>
             </a:r>
           </a:p>
         </p:txBody>
@@ -4493,7 +4493,7 @@
               </a:defRPr>
             </a:pPr>
             <a:r>
-              <a:t>▸  As Christians: we trust God's wisdom to define right and wrong</a:t>
+              <a:t>▸  Even when it's inconvenient or goes against what everyone around us is doing</a:t>
             </a:r>
           </a:p>
         </p:txBody>

</xml_diff>